<commit_message>
Deploying to gh-pages from @ tamanh-oxford/capacity-development@23fc060825250a82c97bdff18b782063d3f275b8 🚀
</commit_message>
<xml_diff>
--- a/data-frameworks/11-best-practice-capacity-building.pptx
+++ b/data-frameworks/11-best-practice-capacity-building.pptx
@@ -18,6 +18,14 @@
     <p:sldId id="266" r:id="rId12"/>
     <p:sldId id="267" r:id="rId13"/>
     <p:sldId id="268" r:id="rId14"/>
+    <p:sldId id="269" r:id="rId15"/>
+    <p:sldId id="270" r:id="rId16"/>
+    <p:sldId id="271" r:id="rId17"/>
+    <p:sldId id="272" r:id="rId18"/>
+    <p:sldId id="273" r:id="rId19"/>
+    <p:sldId id="274" r:id="rId20"/>
+    <p:sldId id="275" r:id="rId21"/>
+    <p:sldId id="276" r:id="rId22"/>
   </p:sldIdLst>
   <p:sldSz cx="9144000" cy="5143500" type="screen16x9"/>
   <p:notesSz cx="6858000" cy="9144000"/>
@@ -3206,11 +3214,41 @@
             </a:pPr>
             <a:r>
               <a:rPr/>
-              <a:t>3. Operationalise data capacity building</a:t>
-            </a:r>
-          </a:p>
-        </p:txBody>
-      </p:sp>
+              <a:t>Data Maturity Assessment Framework</a:t>
+            </a:r>
+          </a:p>
+        </p:txBody>
+      </p:sp>
+      <p:pic>
+        <p:nvPicPr>
+          <p:cNvPr descr="../images/hr_roles_05.png" id="0" name="Picture 1"/>
+          <p:cNvPicPr>
+            <a:picLocks noGrp="1" noChangeAspect="1"/>
+          </p:cNvPicPr>
+          <p:nvPr/>
+        </p:nvPicPr>
+        <p:blipFill>
+          <a:blip r:embed="rId2"/>
+          <a:stretch>
+            <a:fillRect/>
+          </a:stretch>
+        </p:blipFill>
+        <p:spPr bwMode="auto">
+          <a:xfrm>
+            <a:off x="457200" y="1676400"/>
+            <a:ext cx="8229600" cy="2425700"/>
+          </a:xfrm>
+          <a:prstGeom prst="rect">
+            <a:avLst/>
+          </a:prstGeom>
+          <a:noFill/>
+          <a:ln w="9525">
+            <a:noFill/>
+            <a:headEnd/>
+            <a:tailEnd/>
+          </a:ln>
+        </p:spPr>
+      </p:pic>
     </p:spTree>
   </p:cSld>
 </p:sld>
@@ -3253,7 +3291,7 @@
             </a:pPr>
             <a:r>
               <a:rPr/>
-              <a:t>Short-term</a:t>
+              <a:t>Data Maturity Assessment Framework</a:t>
             </a:r>
           </a:p>
         </p:txBody>
@@ -3275,22 +3313,23 @@
           <a:p>
             <a:pPr lvl="0"/>
             <a:r>
+              <a:rPr b="1"/>
+              <a:t>Themes:</a:t>
+            </a:r>
+            <a:r>
               <a:rPr/>
-              <a:t>Training workshops</a:t>
+              <a:t> Uses, Data, Leadership, Culture, Tools, Skills</a:t>
             </a:r>
           </a:p>
           <a:p>
             <a:pPr lvl="0"/>
             <a:r>
+              <a:rPr b="1"/>
+              <a:t>Maturity Levels:</a:t>
+            </a:r>
+            <a:r>
               <a:rPr/>
-              <a:t>Online training resources</a:t>
-            </a:r>
-          </a:p>
-          <a:p>
-            <a:pPr lvl="0"/>
-            <a:r>
-              <a:rPr/>
-              <a:t>Knowledge sharing on global innovations and use cases</a:t>
+              <a:t> Beginning, Emerging, Learning, Developing, Mastering</a:t>
             </a:r>
           </a:p>
         </p:txBody>
@@ -3337,69 +3376,41 @@
             </a:pPr>
             <a:r>
               <a:rPr/>
-              <a:t>Medium-term</a:t>
-            </a:r>
-          </a:p>
-        </p:txBody>
-      </p:sp>
-      <p:sp>
-        <p:nvSpPr>
-          <p:cNvPr id="3" name="Content Placeholder 2"/>
-          <p:cNvSpPr>
-            <a:spLocks noGrp="1"/>
-          </p:cNvSpPr>
-          <p:nvPr>
-            <p:ph idx="1"/>
-          </p:nvPr>
-        </p:nvSpPr>
-        <p:spPr/>
-        <p:txBody>
-          <a:bodyPr/>
-          <a:lstStyle/>
-          <a:p>
-            <a:pPr lvl="0"/>
-            <a:r>
-              <a:rPr/>
-              <a:t>Internal data champions</a:t>
-            </a:r>
-          </a:p>
-          <a:p>
-            <a:pPr lvl="0"/>
-            <a:r>
-              <a:rPr/>
-              <a:t>Periodic data skills training</a:t>
-            </a:r>
-          </a:p>
-          <a:p>
-            <a:pPr lvl="0"/>
-            <a:r>
-              <a:rPr/>
-              <a:t>‍Pilot data projects</a:t>
-            </a:r>
-          </a:p>
-          <a:p>
-            <a:pPr lvl="0"/>
-            <a:r>
-              <a:rPr/>
-              <a:t>‍Build complementary skills with other stakeholders</a:t>
-            </a:r>
-          </a:p>
-          <a:p>
-            <a:pPr lvl="0"/>
-            <a:r>
-              <a:rPr/>
-              <a:t>‍Build on local knowledge and capacities</a:t>
-            </a:r>
-          </a:p>
-          <a:p>
-            <a:pPr lvl="0"/>
-            <a:r>
-              <a:rPr/>
-              <a:t>‍Build network of data practitioners across your organization</a:t>
-            </a:r>
-          </a:p>
-        </p:txBody>
-      </p:sp>
+              <a:t>Data Maturity Assessment Framework - example</a:t>
+            </a:r>
+          </a:p>
+        </p:txBody>
+      </p:sp>
+      <p:pic>
+        <p:nvPicPr>
+          <p:cNvPr descr="../images/dma_example.png" id="0" name="Picture 1"/>
+          <p:cNvPicPr>
+            <a:picLocks noGrp="1" noChangeAspect="1"/>
+          </p:cNvPicPr>
+          <p:nvPr/>
+        </p:nvPicPr>
+        <p:blipFill>
+          <a:blip r:embed="rId2"/>
+          <a:stretch>
+            <a:fillRect/>
+          </a:stretch>
+        </p:blipFill>
+        <p:spPr bwMode="auto">
+          <a:xfrm>
+            <a:off x="1193800" y="1193800"/>
+            <a:ext cx="6756400" cy="3390900"/>
+          </a:xfrm>
+          <a:prstGeom prst="rect">
+            <a:avLst/>
+          </a:prstGeom>
+          <a:noFill/>
+          <a:ln w="9525">
+            <a:noFill/>
+            <a:headEnd/>
+            <a:tailEnd/>
+          </a:ln>
+        </p:spPr>
+      </p:pic>
     </p:spTree>
   </p:cSld>
 </p:sld>
@@ -3442,11 +3453,63 @@
             </a:pPr>
             <a:r>
               <a:rPr/>
-              <a:t>Long-term</a:t>
-            </a:r>
-          </a:p>
-        </p:txBody>
-      </p:sp>
+              <a:t>Data Maturity Assessment Framework Guide</a:t>
+            </a:r>
+          </a:p>
+        </p:txBody>
+      </p:sp>
+      <p:pic>
+        <p:nvPicPr>
+          <p:cNvPr descr="../images/qrcode_assets.publishing.service.gov.uk.png" id="0" name="Picture 1"/>
+          <p:cNvPicPr>
+            <a:picLocks noGrp="1" noChangeAspect="1"/>
+          </p:cNvPicPr>
+          <p:nvPr/>
+        </p:nvPicPr>
+        <p:blipFill>
+          <a:blip r:embed="rId2"/>
+          <a:stretch>
+            <a:fillRect/>
+          </a:stretch>
+        </p:blipFill>
+        <p:spPr bwMode="auto">
+          <a:xfrm>
+            <a:off x="2870200" y="1193800"/>
+            <a:ext cx="3390900" cy="3390900"/>
+          </a:xfrm>
+          <a:prstGeom prst="rect">
+            <a:avLst/>
+          </a:prstGeom>
+          <a:noFill/>
+          <a:ln w="9525">
+            <a:noFill/>
+            <a:headEnd/>
+            <a:tailEnd/>
+          </a:ln>
+        </p:spPr>
+      </p:pic>
+    </p:spTree>
+  </p:cSld>
+</p:sld>
+</file>
+
+<file path=ppt/slides/slide14.xml><?xml version="1.0" encoding="utf-8"?>
+<p:sld xmlns:a="http://schemas.openxmlformats.org/drawingml/2006/main" xmlns:r="http://schemas.openxmlformats.org/officeDocument/2006/relationships" xmlns:p="http://schemas.openxmlformats.org/presentationml/2006/main">
+  <p:cSld>
+    <p:spTree>
+      <p:nvGrpSpPr>
+        <p:cNvPr id="1" name=""/>
+        <p:cNvGrpSpPr/>
+        <p:nvPr/>
+      </p:nvGrpSpPr>
+      <p:grpSpPr>
+        <a:xfrm>
+          <a:off x="0" y="0"/>
+          <a:ext cx="0" cy="0"/>
+          <a:chOff x="0" y="0"/>
+          <a:chExt cx="0" cy="0"/>
+        </a:xfrm>
+      </p:grpSpPr>
       <p:sp>
         <p:nvSpPr>
           <p:cNvPr id="3" name="Content Placeholder 2"/>
@@ -3462,31 +3525,346 @@
           <a:bodyPr/>
           <a:lstStyle/>
           <a:p>
+            <a:pPr lvl="0" indent="0" marL="0">
+              <a:buNone/>
+            </a:pPr>
+            <a:r>
+              <a:rPr>
+                <a:hlinkClick r:id="rId2"/>
+              </a:rPr>
+              <a:t>Link</a:t>
+            </a:r>
+          </a:p>
+        </p:txBody>
+      </p:sp>
+    </p:spTree>
+  </p:cSld>
+</p:sld>
+</file>
+
+<file path=ppt/slides/slide15.xml><?xml version="1.0" encoding="utf-8"?>
+<p:sld xmlns:a="http://schemas.openxmlformats.org/drawingml/2006/main" xmlns:r="http://schemas.openxmlformats.org/officeDocument/2006/relationships" xmlns:p="http://schemas.openxmlformats.org/presentationml/2006/main">
+  <p:cSld>
+    <p:spTree>
+      <p:nvGrpSpPr>
+        <p:cNvPr id="1" name=""/>
+        <p:cNvGrpSpPr/>
+        <p:nvPr/>
+      </p:nvGrpSpPr>
+      <p:grpSpPr>
+        <a:xfrm>
+          <a:off x="0" y="0"/>
+          <a:ext cx="0" cy="0"/>
+          <a:chOff x="0" y="0"/>
+          <a:chExt cx="0" cy="0"/>
+        </a:xfrm>
+      </p:grpSpPr>
+      <p:sp>
+        <p:nvSpPr>
+          <p:cNvPr id="2" name="Title 1"/>
+          <p:cNvSpPr>
+            <a:spLocks noGrp="1"/>
+          </p:cNvSpPr>
+          <p:nvPr>
+            <p:ph type="title"/>
+          </p:nvPr>
+        </p:nvSpPr>
+        <p:spPr/>
+        <p:txBody>
+          <a:bodyPr/>
+          <a:lstStyle/>
+          <a:p>
+            <a:pPr lvl="0" indent="0" marL="0">
+              <a:buNone/>
+            </a:pPr>
+            <a:r>
+              <a:rPr/>
+              <a:t>2. Build data capacities in your team</a:t>
+            </a:r>
+          </a:p>
+        </p:txBody>
+      </p:sp>
+    </p:spTree>
+  </p:cSld>
+</p:sld>
+</file>
+
+<file path=ppt/slides/slide16.xml><?xml version="1.0" encoding="utf-8"?>
+<p:sld xmlns:a="http://schemas.openxmlformats.org/drawingml/2006/main" xmlns:r="http://schemas.openxmlformats.org/officeDocument/2006/relationships" xmlns:p="http://schemas.openxmlformats.org/presentationml/2006/main">
+  <p:cSld>
+    <p:spTree>
+      <p:nvGrpSpPr>
+        <p:cNvPr id="1" name=""/>
+        <p:cNvGrpSpPr/>
+        <p:nvPr/>
+      </p:nvGrpSpPr>
+      <p:grpSpPr>
+        <a:xfrm>
+          <a:off x="0" y="0"/>
+          <a:ext cx="0" cy="0"/>
+          <a:chOff x="0" y="0"/>
+          <a:chExt cx="0" cy="0"/>
+        </a:xfrm>
+      </p:grpSpPr>
+      <p:sp>
+        <p:nvSpPr>
+          <p:cNvPr id="2" name="Title 1"/>
+          <p:cNvSpPr>
+            <a:spLocks noGrp="1"/>
+          </p:cNvSpPr>
+          <p:nvPr>
+            <p:ph type="title"/>
+          </p:nvPr>
+        </p:nvSpPr>
+        <p:spPr/>
+        <p:txBody>
+          <a:bodyPr/>
+          <a:lstStyle/>
+          <a:p>
+            <a:pPr lvl="0" indent="0" marL="0">
+              <a:buNone/>
+            </a:pPr>
+            <a:r>
+              <a:rPr/>
+              <a:t>Data Literacy</a:t>
+            </a:r>
+          </a:p>
+        </p:txBody>
+      </p:sp>
+      <p:pic>
+        <p:nvPicPr>
+          <p:cNvPr descr="../images/hr_roles_06.png" id="0" name="Picture 1"/>
+          <p:cNvPicPr>
+            <a:picLocks noGrp="1" noChangeAspect="1"/>
+          </p:cNvPicPr>
+          <p:nvPr/>
+        </p:nvPicPr>
+        <p:blipFill>
+          <a:blip r:embed="rId2"/>
+          <a:stretch>
+            <a:fillRect/>
+          </a:stretch>
+        </p:blipFill>
+        <p:spPr bwMode="auto">
+          <a:xfrm>
+            <a:off x="1498600" y="1193800"/>
+            <a:ext cx="6134100" cy="3390900"/>
+          </a:xfrm>
+          <a:prstGeom prst="rect">
+            <a:avLst/>
+          </a:prstGeom>
+          <a:noFill/>
+          <a:ln w="9525">
+            <a:noFill/>
+            <a:headEnd/>
+            <a:tailEnd/>
+          </a:ln>
+        </p:spPr>
+      </p:pic>
+    </p:spTree>
+  </p:cSld>
+</p:sld>
+</file>
+
+<file path=ppt/slides/slide17.xml><?xml version="1.0" encoding="utf-8"?>
+<p:sld xmlns:a="http://schemas.openxmlformats.org/drawingml/2006/main" xmlns:r="http://schemas.openxmlformats.org/officeDocument/2006/relationships" xmlns:p="http://schemas.openxmlformats.org/presentationml/2006/main">
+  <p:cSld>
+    <p:spTree>
+      <p:nvGrpSpPr>
+        <p:cNvPr id="1" name=""/>
+        <p:cNvGrpSpPr/>
+        <p:nvPr/>
+      </p:nvGrpSpPr>
+      <p:grpSpPr>
+        <a:xfrm>
+          <a:off x="0" y="0"/>
+          <a:ext cx="0" cy="0"/>
+          <a:chOff x="0" y="0"/>
+          <a:chExt cx="0" cy="0"/>
+        </a:xfrm>
+      </p:grpSpPr>
+      <p:sp>
+        <p:nvSpPr>
+          <p:cNvPr id="2" name="Title 1"/>
+          <p:cNvSpPr>
+            <a:spLocks noGrp="1"/>
+          </p:cNvSpPr>
+          <p:nvPr>
+            <p:ph type="title"/>
+          </p:nvPr>
+        </p:nvSpPr>
+        <p:spPr/>
+        <p:txBody>
+          <a:bodyPr/>
+          <a:lstStyle/>
+          <a:p>
+            <a:pPr lvl="0" indent="0" marL="0">
+              <a:buNone/>
+            </a:pPr>
+            <a:r>
+              <a:rPr/>
+              <a:t>Data Skills Framework</a:t>
+            </a:r>
+          </a:p>
+        </p:txBody>
+      </p:sp>
+      <p:pic>
+        <p:nvPicPr>
+          <p:cNvPr descr="../images/hr_roles_07.png" id="0" name="Picture 1"/>
+          <p:cNvPicPr>
+            <a:picLocks noGrp="1" noChangeAspect="1"/>
+          </p:cNvPicPr>
+          <p:nvPr/>
+        </p:nvPicPr>
+        <p:blipFill>
+          <a:blip r:embed="rId2"/>
+          <a:stretch>
+            <a:fillRect/>
+          </a:stretch>
+        </p:blipFill>
+        <p:spPr bwMode="auto">
+          <a:xfrm>
+            <a:off x="2171700" y="1193800"/>
+            <a:ext cx="4787900" cy="3390900"/>
+          </a:xfrm>
+          <a:prstGeom prst="rect">
+            <a:avLst/>
+          </a:prstGeom>
+          <a:noFill/>
+          <a:ln w="9525">
+            <a:noFill/>
+            <a:headEnd/>
+            <a:tailEnd/>
+          </a:ln>
+        </p:spPr>
+      </p:pic>
+    </p:spTree>
+  </p:cSld>
+</p:sld>
+</file>
+
+<file path=ppt/slides/slide18.xml><?xml version="1.0" encoding="utf-8"?>
+<p:sld xmlns:a="http://schemas.openxmlformats.org/drawingml/2006/main" xmlns:r="http://schemas.openxmlformats.org/officeDocument/2006/relationships" xmlns:p="http://schemas.openxmlformats.org/presentationml/2006/main">
+  <p:cSld>
+    <p:spTree>
+      <p:nvGrpSpPr>
+        <p:cNvPr id="1" name=""/>
+        <p:cNvGrpSpPr/>
+        <p:nvPr/>
+      </p:nvGrpSpPr>
+      <p:grpSpPr>
+        <a:xfrm>
+          <a:off x="0" y="0"/>
+          <a:ext cx="0" cy="0"/>
+          <a:chOff x="0" y="0"/>
+          <a:chExt cx="0" cy="0"/>
+        </a:xfrm>
+      </p:grpSpPr>
+      <p:sp>
+        <p:nvSpPr>
+          <p:cNvPr id="2" name="Title 1"/>
+          <p:cNvSpPr>
+            <a:spLocks noGrp="1"/>
+          </p:cNvSpPr>
+          <p:nvPr>
+            <p:ph type="title"/>
+          </p:nvPr>
+        </p:nvSpPr>
+        <p:spPr/>
+        <p:txBody>
+          <a:bodyPr/>
+          <a:lstStyle/>
+          <a:p>
+            <a:pPr lvl="0" indent="0" marL="0">
+              <a:buNone/>
+            </a:pPr>
+            <a:r>
+              <a:rPr/>
+              <a:t>3. Operationalise data capacity building</a:t>
+            </a:r>
+          </a:p>
+        </p:txBody>
+      </p:sp>
+    </p:spTree>
+  </p:cSld>
+</p:sld>
+</file>
+
+<file path=ppt/slides/slide19.xml><?xml version="1.0" encoding="utf-8"?>
+<p:sld xmlns:a="http://schemas.openxmlformats.org/drawingml/2006/main" xmlns:r="http://schemas.openxmlformats.org/officeDocument/2006/relationships" xmlns:p="http://schemas.openxmlformats.org/presentationml/2006/main">
+  <p:cSld>
+    <p:spTree>
+      <p:nvGrpSpPr>
+        <p:cNvPr id="1" name=""/>
+        <p:cNvGrpSpPr/>
+        <p:nvPr/>
+      </p:nvGrpSpPr>
+      <p:grpSpPr>
+        <a:xfrm>
+          <a:off x="0" y="0"/>
+          <a:ext cx="0" cy="0"/>
+          <a:chOff x="0" y="0"/>
+          <a:chExt cx="0" cy="0"/>
+        </a:xfrm>
+      </p:grpSpPr>
+      <p:sp>
+        <p:nvSpPr>
+          <p:cNvPr id="2" name="Title 1"/>
+          <p:cNvSpPr>
+            <a:spLocks noGrp="1"/>
+          </p:cNvSpPr>
+          <p:nvPr>
+            <p:ph type="title"/>
+          </p:nvPr>
+        </p:nvSpPr>
+        <p:spPr/>
+        <p:txBody>
+          <a:bodyPr/>
+          <a:lstStyle/>
+          <a:p>
+            <a:pPr lvl="0" indent="0" marL="0">
+              <a:buNone/>
+            </a:pPr>
+            <a:r>
+              <a:rPr/>
+              <a:t>Short-term</a:t>
+            </a:r>
+          </a:p>
+        </p:txBody>
+      </p:sp>
+      <p:sp>
+        <p:nvSpPr>
+          <p:cNvPr id="3" name="Content Placeholder 2"/>
+          <p:cNvSpPr>
+            <a:spLocks noGrp="1"/>
+          </p:cNvSpPr>
+          <p:nvPr>
+            <p:ph idx="1"/>
+          </p:nvPr>
+        </p:nvSpPr>
+        <p:spPr/>
+        <p:txBody>
+          <a:bodyPr/>
+          <a:lstStyle/>
+          <a:p>
             <a:pPr lvl="0"/>
             <a:r>
               <a:rPr/>
-              <a:t>Embed data skills in job roles</a:t>
+              <a:t>Training workshops</a:t>
             </a:r>
           </a:p>
           <a:p>
             <a:pPr lvl="0"/>
             <a:r>
               <a:rPr/>
-              <a:t>Institutionalize data training programs</a:t>
+              <a:t>Online training resources</a:t>
             </a:r>
           </a:p>
           <a:p>
             <a:pPr lvl="0"/>
             <a:r>
               <a:rPr/>
-              <a:t>‍Partner with think tanks and external organizations</a:t>
-            </a:r>
-          </a:p>
-          <a:p>
-            <a:pPr lvl="0"/>
-            <a:r>
-              <a:rPr/>
-              <a:t>‍Partner with academia and local universities</a:t>
+              <a:t>Knowledge sharing on global innovations and use cases</a:t>
             </a:r>
           </a:p>
         </p:txBody>
@@ -3577,7 +3955,203 @@
             <a:pPr lvl="0"/>
             <a:r>
               <a:rPr/>
-              <a:t>Complementary skillsets help reinforce the entire data value chain and improve overall decision-making.</a:t>
+              <a:t>Complementary skill sets help reinforce the entire data value chain and improve overall decision-making.</a:t>
+            </a:r>
+          </a:p>
+        </p:txBody>
+      </p:sp>
+    </p:spTree>
+  </p:cSld>
+</p:sld>
+</file>
+
+<file path=ppt/slides/slide20.xml><?xml version="1.0" encoding="utf-8"?>
+<p:sld xmlns:a="http://schemas.openxmlformats.org/drawingml/2006/main" xmlns:r="http://schemas.openxmlformats.org/officeDocument/2006/relationships" xmlns:p="http://schemas.openxmlformats.org/presentationml/2006/main">
+  <p:cSld>
+    <p:spTree>
+      <p:nvGrpSpPr>
+        <p:cNvPr id="1" name=""/>
+        <p:cNvGrpSpPr/>
+        <p:nvPr/>
+      </p:nvGrpSpPr>
+      <p:grpSpPr>
+        <a:xfrm>
+          <a:off x="0" y="0"/>
+          <a:ext cx="0" cy="0"/>
+          <a:chOff x="0" y="0"/>
+          <a:chExt cx="0" cy="0"/>
+        </a:xfrm>
+      </p:grpSpPr>
+      <p:sp>
+        <p:nvSpPr>
+          <p:cNvPr id="2" name="Title 1"/>
+          <p:cNvSpPr>
+            <a:spLocks noGrp="1"/>
+          </p:cNvSpPr>
+          <p:nvPr>
+            <p:ph type="title"/>
+          </p:nvPr>
+        </p:nvSpPr>
+        <p:spPr/>
+        <p:txBody>
+          <a:bodyPr/>
+          <a:lstStyle/>
+          <a:p>
+            <a:pPr lvl="0" indent="0" marL="0">
+              <a:buNone/>
+            </a:pPr>
+            <a:r>
+              <a:rPr/>
+              <a:t>Medium-term</a:t>
+            </a:r>
+          </a:p>
+        </p:txBody>
+      </p:sp>
+      <p:sp>
+        <p:nvSpPr>
+          <p:cNvPr id="3" name="Content Placeholder 2"/>
+          <p:cNvSpPr>
+            <a:spLocks noGrp="1"/>
+          </p:cNvSpPr>
+          <p:nvPr>
+            <p:ph idx="1"/>
+          </p:nvPr>
+        </p:nvSpPr>
+        <p:spPr/>
+        <p:txBody>
+          <a:bodyPr/>
+          <a:lstStyle/>
+          <a:p>
+            <a:pPr lvl="0"/>
+            <a:r>
+              <a:rPr/>
+              <a:t>Internal data champions</a:t>
+            </a:r>
+          </a:p>
+          <a:p>
+            <a:pPr lvl="0"/>
+            <a:r>
+              <a:rPr/>
+              <a:t>Periodic data skills training</a:t>
+            </a:r>
+          </a:p>
+          <a:p>
+            <a:pPr lvl="0"/>
+            <a:r>
+              <a:rPr/>
+              <a:t>‍Pilot data projects</a:t>
+            </a:r>
+          </a:p>
+          <a:p>
+            <a:pPr lvl="0"/>
+            <a:r>
+              <a:rPr/>
+              <a:t>‍Build complementary skills with other stakeholders</a:t>
+            </a:r>
+          </a:p>
+          <a:p>
+            <a:pPr lvl="0"/>
+            <a:r>
+              <a:rPr/>
+              <a:t>‍Build on local knowledge and capacities</a:t>
+            </a:r>
+          </a:p>
+          <a:p>
+            <a:pPr lvl="0"/>
+            <a:r>
+              <a:rPr/>
+              <a:t>‍Build network of data practitioners across your organization</a:t>
+            </a:r>
+          </a:p>
+        </p:txBody>
+      </p:sp>
+    </p:spTree>
+  </p:cSld>
+</p:sld>
+</file>
+
+<file path=ppt/slides/slide21.xml><?xml version="1.0" encoding="utf-8"?>
+<p:sld xmlns:a="http://schemas.openxmlformats.org/drawingml/2006/main" xmlns:r="http://schemas.openxmlformats.org/officeDocument/2006/relationships" xmlns:p="http://schemas.openxmlformats.org/presentationml/2006/main">
+  <p:cSld>
+    <p:spTree>
+      <p:nvGrpSpPr>
+        <p:cNvPr id="1" name=""/>
+        <p:cNvGrpSpPr/>
+        <p:nvPr/>
+      </p:nvGrpSpPr>
+      <p:grpSpPr>
+        <a:xfrm>
+          <a:off x="0" y="0"/>
+          <a:ext cx="0" cy="0"/>
+          <a:chOff x="0" y="0"/>
+          <a:chExt cx="0" cy="0"/>
+        </a:xfrm>
+      </p:grpSpPr>
+      <p:sp>
+        <p:nvSpPr>
+          <p:cNvPr id="2" name="Title 1"/>
+          <p:cNvSpPr>
+            <a:spLocks noGrp="1"/>
+          </p:cNvSpPr>
+          <p:nvPr>
+            <p:ph type="title"/>
+          </p:nvPr>
+        </p:nvSpPr>
+        <p:spPr/>
+        <p:txBody>
+          <a:bodyPr/>
+          <a:lstStyle/>
+          <a:p>
+            <a:pPr lvl="0" indent="0" marL="0">
+              <a:buNone/>
+            </a:pPr>
+            <a:r>
+              <a:rPr/>
+              <a:t>Long-term</a:t>
+            </a:r>
+          </a:p>
+        </p:txBody>
+      </p:sp>
+      <p:sp>
+        <p:nvSpPr>
+          <p:cNvPr id="3" name="Content Placeholder 2"/>
+          <p:cNvSpPr>
+            <a:spLocks noGrp="1"/>
+          </p:cNvSpPr>
+          <p:nvPr>
+            <p:ph idx="1"/>
+          </p:nvPr>
+        </p:nvSpPr>
+        <p:spPr/>
+        <p:txBody>
+          <a:bodyPr/>
+          <a:lstStyle/>
+          <a:p>
+            <a:pPr lvl="0"/>
+            <a:r>
+              <a:rPr/>
+              <a:t>Embed data skills in job roles</a:t>
+            </a:r>
+          </a:p>
+          <a:p>
+            <a:pPr lvl="0"/>
+            <a:r>
+              <a:rPr/>
+              <a:t>Institutionalize data training programs</a:t>
+            </a:r>
+          </a:p>
+          <a:p>
+            <a:pPr lvl="0"/>
+            <a:r>
+              <a:rPr/>
+              <a:t>‍Partner with think tanks and external organizations</a:t>
+            </a:r>
+          </a:p>
+          <a:p>
+            <a:pPr lvl="0"/>
+            <a:r>
+              <a:rPr/>
+              <a:t>‍Partner with academia and local universities</a:t>
             </a:r>
           </a:p>
         </p:txBody>
@@ -3825,41 +4399,49 @@
             </a:pPr>
             <a:r>
               <a:rPr/>
-              <a:t>Data Maturity Assessment Framework</a:t>
-            </a:r>
-          </a:p>
-        </p:txBody>
-      </p:sp>
-      <p:pic>
-        <p:nvPicPr>
-          <p:cNvPr descr="../images/hr_roles_05.png" id="0" name="Picture 1"/>
-          <p:cNvPicPr>
-            <a:picLocks noGrp="1" noChangeAspect="1"/>
-          </p:cNvPicPr>
-          <p:nvPr/>
-        </p:nvPicPr>
-        <p:blipFill>
-          <a:blip r:embed="rId2"/>
-          <a:stretch>
-            <a:fillRect/>
-          </a:stretch>
-        </p:blipFill>
-        <p:spPr bwMode="auto">
-          <a:xfrm>
-            <a:off x="457200" y="1676400"/>
-            <a:ext cx="8229600" cy="2425700"/>
-          </a:xfrm>
-          <a:prstGeom prst="rect">
-            <a:avLst/>
-          </a:prstGeom>
-          <a:noFill/>
-          <a:ln w="9525">
-            <a:noFill/>
-            <a:headEnd/>
-            <a:tailEnd/>
-          </a:ln>
-        </p:spPr>
-      </p:pic>
+              <a:t>Data Capability Framework - example</a:t>
+            </a:r>
+          </a:p>
+        </p:txBody>
+      </p:sp>
+      <p:sp>
+        <p:nvSpPr>
+          <p:cNvPr id="3" name="Content Placeholder 2"/>
+          <p:cNvSpPr>
+            <a:spLocks noGrp="1"/>
+          </p:cNvSpPr>
+          <p:nvPr>
+            <p:ph idx="1"/>
+          </p:nvPr>
+        </p:nvSpPr>
+        <p:spPr/>
+        <p:txBody>
+          <a:bodyPr/>
+          <a:lstStyle/>
+          <a:p>
+            <a:pPr lvl="0"/>
+            <a:r>
+              <a:rPr b="1"/>
+              <a:t>Capability:</a:t>
+            </a:r>
+            <a:r>
+              <a:rPr/>
+              <a:t> Employ data coding and classification principles</a:t>
+            </a:r>
+          </a:p>
+          <a:p>
+            <a:pPr lvl="0"/>
+            <a:r>
+              <a:rPr b="1"/>
+              <a:t>Catgory:</a:t>
+            </a:r>
+            <a:r>
+              <a:rPr/>
+              <a:t> Describe, Store, Use, and Save/Destroy</a:t>
+            </a:r>
+          </a:p>
+        </p:txBody>
+      </p:sp>
     </p:spTree>
   </p:cSld>
 </p:sld>
@@ -3884,12 +4466,12 @@
       </p:grpSpPr>
       <p:sp>
         <p:nvSpPr>
-          <p:cNvPr id="2" name="Title 1"/>
-          <p:cNvSpPr>
-            <a:spLocks noGrp="1"/>
-          </p:cNvSpPr>
-          <p:nvPr>
-            <p:ph type="title"/>
+          <p:cNvPr id="3" name="Content Placeholder 2"/>
+          <p:cNvSpPr>
+            <a:spLocks noGrp="1"/>
+          </p:cNvSpPr>
+          <p:nvPr>
+            <p:ph idx="1" sz="half"/>
           </p:nvPr>
         </p:nvSpPr>
         <p:spPr/>
@@ -3898,11 +4480,70 @@
           <a:lstStyle/>
           <a:p>
             <a:pPr lvl="0" indent="0" marL="0">
+              <a:spcBef>
+                <a:spcPts val="3000"/>
+              </a:spcBef>
               <a:buNone/>
             </a:pPr>
             <a:r>
+              <a:rPr b="1"/>
+              <a:t>New</a:t>
+            </a:r>
+          </a:p>
+          <a:p>
+            <a:pPr lvl="0"/>
+            <a:r>
               <a:rPr/>
-              <a:t>2. Build data capacities in your team</a:t>
+              <a:t>Is aware of relevant data classifications and coding protocols, and their proper application to data in general.</a:t>
+            </a:r>
+          </a:p>
+          <a:p>
+            <a:pPr lvl="0"/>
+            <a:r>
+              <a:rPr/>
+              <a:t>Knows who to consult for expert knowledge.</a:t>
+            </a:r>
+          </a:p>
+        </p:txBody>
+      </p:sp>
+      <p:sp>
+        <p:nvSpPr>
+          <p:cNvPr id="4" name="Content Placeholder 3"/>
+          <p:cNvSpPr>
+            <a:spLocks noGrp="1"/>
+          </p:cNvSpPr>
+          <p:nvPr>
+            <p:ph idx="2" sz="half"/>
+          </p:nvPr>
+        </p:nvSpPr>
+        <p:spPr/>
+        <p:txBody>
+          <a:bodyPr/>
+          <a:lstStyle/>
+          <a:p>
+            <a:pPr lvl="0" indent="0" marL="0">
+              <a:spcBef>
+                <a:spcPts val="3000"/>
+              </a:spcBef>
+              <a:buNone/>
+            </a:pPr>
+            <a:r>
+              <a:rPr b="1"/>
+              <a:t>Proficient</a:t>
+            </a:r>
+          </a:p>
+          <a:p>
+            <a:pPr lvl="0"/>
+            <a:r>
+              <a:rPr/>
+              <a:t>Has a comprehensive knowledge of data classifications and coding protocols.</a:t>
+            </a:r>
+          </a:p>
+          <a:p>
+            <a:pPr lvl="0"/>
+            <a:r>
+              <a:rPr/>
+              <a:t>Knows where to obtain expert advice about coding and classifications as needed.</a:t>
             </a:r>
           </a:p>
         </p:txBody>
@@ -3949,14 +4590,14 @@
             </a:pPr>
             <a:r>
               <a:rPr/>
-              <a:t>Data Literacy</a:t>
+              <a:t>Data Capability Framework Guide</a:t>
             </a:r>
           </a:p>
         </p:txBody>
       </p:sp>
       <p:pic>
         <p:nvPicPr>
-          <p:cNvPr descr="../images/hr_roles_06.png" id="0" name="Picture 1"/>
+          <p:cNvPr descr="../images/qrcode_data.govt.nz.png" id="0" name="Picture 1"/>
           <p:cNvPicPr>
             <a:picLocks noGrp="1" noChangeAspect="1"/>
           </p:cNvPicPr>
@@ -3970,8 +4611,8 @@
         </p:blipFill>
         <p:spPr bwMode="auto">
           <a:xfrm>
-            <a:off x="1498600" y="1193800"/>
-            <a:ext cx="6134100" cy="3390900"/>
+            <a:off x="2870200" y="1193800"/>
+            <a:ext cx="3390900" cy="3390900"/>
           </a:xfrm>
           <a:prstGeom prst="rect">
             <a:avLst/>
@@ -4008,12 +4649,12 @@
       </p:grpSpPr>
       <p:sp>
         <p:nvSpPr>
-          <p:cNvPr id="2" name="Title 1"/>
-          <p:cNvSpPr>
-            <a:spLocks noGrp="1"/>
-          </p:cNvSpPr>
-          <p:nvPr>
-            <p:ph type="title"/>
+          <p:cNvPr id="3" name="Content Placeholder 2"/>
+          <p:cNvSpPr>
+            <a:spLocks noGrp="1"/>
+          </p:cNvSpPr>
+          <p:nvPr>
+            <p:ph idx="1"/>
           </p:nvPr>
         </p:nvSpPr>
         <p:spPr/>
@@ -4025,42 +4666,14 @@
               <a:buNone/>
             </a:pPr>
             <a:r>
-              <a:rPr/>
-              <a:t>Data Skills Framework</a:t>
-            </a:r>
-          </a:p>
-        </p:txBody>
-      </p:sp>
-      <p:pic>
-        <p:nvPicPr>
-          <p:cNvPr descr="../images/hr_roles_07.png" id="0" name="Picture 1"/>
-          <p:cNvPicPr>
-            <a:picLocks noGrp="1" noChangeAspect="1"/>
-          </p:cNvPicPr>
-          <p:nvPr/>
-        </p:nvPicPr>
-        <p:blipFill>
-          <a:blip r:embed="rId2"/>
-          <a:stretch>
-            <a:fillRect/>
-          </a:stretch>
-        </p:blipFill>
-        <p:spPr bwMode="auto">
-          <a:xfrm>
-            <a:off x="2171700" y="1193800"/>
-            <a:ext cx="4787900" cy="3390900"/>
-          </a:xfrm>
-          <a:prstGeom prst="rect">
-            <a:avLst/>
-          </a:prstGeom>
-          <a:noFill/>
-          <a:ln w="9525">
-            <a:noFill/>
-            <a:headEnd/>
-            <a:tailEnd/>
-          </a:ln>
-        </p:spPr>
-      </p:pic>
+              <a:rPr>
+                <a:hlinkClick r:id="rId2"/>
+              </a:rPr>
+              <a:t>Link</a:t>
+            </a:r>
+          </a:p>
+        </p:txBody>
+      </p:sp>
     </p:spTree>
   </p:cSld>
 </p:sld>

</xml_diff>